<commit_message>
Correct Ocean logo proportions in shared layouts
</commit_message>
<xml_diff>
--- a/output/pptx/ocean-layout-reference.pptx
+++ b/output/pptx/ocean-layout-reference.pptx
@@ -2243,13 +2243,14 @@
         </p:nvPicPr>
         <p:blipFill>
           <a:blip r:embed="rId1"/>
-          <a:srcRect l="0" r="0" t="0" b="0"/>
-          <a:stretch/>
+          <a:stretch>
+            <a:fillRect/>
+          </a:stretch>
         </p:blipFill>
         <p:spPr>
           <a:xfrm>
-            <a:off x="548640" y="475488"/>
-            <a:ext cx="1371600" cy="292608"/>
+            <a:off x="548640" y="457200"/>
+            <a:ext cx="1143000" cy="319126"/>
           </a:xfrm>
           <a:prstGeom prst="rect">
             <a:avLst/>
@@ -2574,13 +2575,14 @@
         </p:nvPicPr>
         <p:blipFill>
           <a:blip r:embed="rId1"/>
-          <a:srcRect l="0" r="0" t="0" b="0"/>
-          <a:stretch/>
+          <a:stretch>
+            <a:fillRect/>
+          </a:stretch>
         </p:blipFill>
         <p:spPr>
           <a:xfrm>
-            <a:off x="548640" y="475488"/>
-            <a:ext cx="1371600" cy="292608"/>
+            <a:off x="548640" y="457200"/>
+            <a:ext cx="1143000" cy="319126"/>
           </a:xfrm>
           <a:prstGeom prst="rect">
             <a:avLst/>
@@ -3290,13 +3292,14 @@
         </p:nvPicPr>
         <p:blipFill>
           <a:blip r:embed="rId1"/>
-          <a:srcRect l="0" r="0" t="0" b="0"/>
-          <a:stretch/>
+          <a:stretch>
+            <a:fillRect/>
+          </a:stretch>
         </p:blipFill>
         <p:spPr>
           <a:xfrm>
-            <a:off x="548640" y="475488"/>
-            <a:ext cx="1371600" cy="292608"/>
+            <a:off x="548640" y="457200"/>
+            <a:ext cx="1143000" cy="319126"/>
           </a:xfrm>
           <a:prstGeom prst="rect">
             <a:avLst/>
@@ -4083,13 +4086,14 @@
         </p:nvPicPr>
         <p:blipFill>
           <a:blip r:embed="rId1"/>
-          <a:srcRect l="0" r="0" t="0" b="0"/>
-          <a:stretch/>
+          <a:stretch>
+            <a:fillRect/>
+          </a:stretch>
         </p:blipFill>
         <p:spPr>
           <a:xfrm>
-            <a:off x="548640" y="475488"/>
-            <a:ext cx="1371600" cy="292608"/>
+            <a:off x="548640" y="457200"/>
+            <a:ext cx="1143000" cy="319126"/>
           </a:xfrm>
           <a:prstGeom prst="rect">
             <a:avLst/>
@@ -4730,13 +4734,14 @@
         </p:nvPicPr>
         <p:blipFill>
           <a:blip r:embed="rId1"/>
-          <a:srcRect l="0" r="0" t="0" b="0"/>
-          <a:stretch/>
+          <a:stretch>
+            <a:fillRect/>
+          </a:stretch>
         </p:blipFill>
         <p:spPr>
           <a:xfrm>
-            <a:off x="548640" y="475488"/>
-            <a:ext cx="1371600" cy="292608"/>
+            <a:off x="548640" y="457200"/>
+            <a:ext cx="1143000" cy="319126"/>
           </a:xfrm>
           <a:prstGeom prst="rect">
             <a:avLst/>
@@ -6037,13 +6042,14 @@
         </p:nvPicPr>
         <p:blipFill>
           <a:blip r:embed="rId1"/>
-          <a:srcRect l="0" r="0" t="0" b="0"/>
-          <a:stretch/>
+          <a:stretch>
+            <a:fillRect/>
+          </a:stretch>
         </p:blipFill>
         <p:spPr>
           <a:xfrm>
-            <a:off x="548640" y="475488"/>
-            <a:ext cx="1371600" cy="292608"/>
+            <a:off x="548640" y="457200"/>
+            <a:ext cx="1143000" cy="319126"/>
           </a:xfrm>
           <a:prstGeom prst="rect">
             <a:avLst/>
@@ -6325,13 +6331,14 @@
         </p:nvPicPr>
         <p:blipFill>
           <a:blip r:embed="rId1"/>
-          <a:srcRect l="0" r="0" t="0" b="0"/>
-          <a:stretch/>
+          <a:stretch>
+            <a:fillRect/>
+          </a:stretch>
         </p:blipFill>
         <p:spPr>
           <a:xfrm>
-            <a:off x="548640" y="475488"/>
-            <a:ext cx="1371600" cy="292608"/>
+            <a:off x="548640" y="457200"/>
+            <a:ext cx="1143000" cy="319126"/>
           </a:xfrm>
           <a:prstGeom prst="rect">
             <a:avLst/>
@@ -6656,13 +6663,14 @@
         </p:nvPicPr>
         <p:blipFill>
           <a:blip r:embed="rId1"/>
-          <a:srcRect l="0" r="0" t="0" b="0"/>
-          <a:stretch/>
+          <a:stretch>
+            <a:fillRect/>
+          </a:stretch>
         </p:blipFill>
         <p:spPr>
           <a:xfrm>
-            <a:off x="548640" y="475488"/>
-            <a:ext cx="1371600" cy="292608"/>
+            <a:off x="548640" y="457200"/>
+            <a:ext cx="1143000" cy="319126"/>
           </a:xfrm>
           <a:prstGeom prst="rect">
             <a:avLst/>
@@ -7284,13 +7292,14 @@
         </p:nvPicPr>
         <p:blipFill>
           <a:blip r:embed="rId1"/>
-          <a:srcRect l="0" r="0" t="0" b="0"/>
-          <a:stretch/>
+          <a:stretch>
+            <a:fillRect/>
+          </a:stretch>
         </p:blipFill>
         <p:spPr>
           <a:xfrm>
-            <a:off x="548640" y="475488"/>
-            <a:ext cx="1371600" cy="292608"/>
+            <a:off x="548640" y="457200"/>
+            <a:ext cx="1143000" cy="319126"/>
           </a:xfrm>
           <a:prstGeom prst="rect">
             <a:avLst/>
@@ -8097,13 +8106,14 @@
         </p:nvPicPr>
         <p:blipFill>
           <a:blip r:embed="rId1"/>
-          <a:srcRect l="0" r="0" t="0" b="0"/>
-          <a:stretch/>
+          <a:stretch>
+            <a:fillRect/>
+          </a:stretch>
         </p:blipFill>
         <p:spPr>
           <a:xfrm>
-            <a:off x="548640" y="475488"/>
-            <a:ext cx="1371600" cy="292608"/>
+            <a:off x="548640" y="457200"/>
+            <a:ext cx="1143000" cy="319126"/>
           </a:xfrm>
           <a:prstGeom prst="rect">
             <a:avLst/>
@@ -8981,13 +8991,14 @@
         </p:nvPicPr>
         <p:blipFill>
           <a:blip r:embed="rId1"/>
-          <a:srcRect l="0" r="0" t="0" b="0"/>
-          <a:stretch/>
+          <a:stretch>
+            <a:fillRect/>
+          </a:stretch>
         </p:blipFill>
         <p:spPr>
           <a:xfrm>
-            <a:off x="548640" y="475488"/>
-            <a:ext cx="1371600" cy="292608"/>
+            <a:off x="548640" y="457200"/>
+            <a:ext cx="1143000" cy="319126"/>
           </a:xfrm>
           <a:prstGeom prst="rect">
             <a:avLst/>
@@ -9874,13 +9885,14 @@
         </p:nvPicPr>
         <p:blipFill>
           <a:blip r:embed="rId1"/>
-          <a:srcRect l="0" r="0" t="0" b="0"/>
-          <a:stretch/>
+          <a:stretch>
+            <a:fillRect/>
+          </a:stretch>
         </p:blipFill>
         <p:spPr>
           <a:xfrm>
-            <a:off x="548640" y="475488"/>
-            <a:ext cx="1371600" cy="292608"/>
+            <a:off x="548640" y="457200"/>
+            <a:ext cx="1143000" cy="319126"/>
           </a:xfrm>
           <a:prstGeom prst="rect">
             <a:avLst/>
@@ -11387,13 +11399,14 @@
         </p:nvPicPr>
         <p:blipFill>
           <a:blip r:embed="rId1"/>
-          <a:srcRect l="0" r="0" t="0" b="0"/>
-          <a:stretch/>
+          <a:stretch>
+            <a:fillRect/>
+          </a:stretch>
         </p:blipFill>
         <p:spPr>
           <a:xfrm>
-            <a:off x="548640" y="475488"/>
-            <a:ext cx="1371600" cy="292608"/>
+            <a:off x="548640" y="457200"/>
+            <a:ext cx="1143000" cy="319126"/>
           </a:xfrm>
           <a:prstGeom prst="rect">
             <a:avLst/>

</xml_diff>